<commit_message>
Completa as dez apresentações numeradas da dissertação
Acrescenta as versões 01 a 10 com variações acadêmicas em verde escuro, mantendo 12 slides, as leituras nas notas e o cronograma de 15 minutos. Inclui gerador das dez versões, configurações visuais e instruções de regeneração. Ignora arquivos temporários de bloqueio do LibreOffice.
</commit_message>
<xml_diff>
--- a/apresentacao/apresentacao_dissertacao.pptx
+++ b/apresentacao/apresentacao_dissertacao.pptx
@@ -118,14 +118,14 @@
   <p:extLst>
     <p:ext uri="{521415D9-36F7-43E2-AB2F-B90AF26B5E84}">
       <p14:sectionLst xmlns:p14="http://schemas.microsoft.com/office/powerpoint/2010/main">
-        <p14:section name="Abertura" id="{a102f889-aa2b-90c1-a8dc-134ce3bf9c2d}">
+        <p14:section name="Abertura" id="{68be9bd2-ac50-547f-20b1-b8d800701531}">
           <p14:sldIdLst>
             <p14:sldId id="256"/>
             <p14:sldId id="257"/>
             <p14:sldId id="258"/>
           </p14:sldIdLst>
         </p14:section>
-        <p14:section name="Dados e método" id="{41c0e66a-1c3d-5761-8a8c-a0102f433485}">
+        <p14:section name="Dados e método" id="{2d735a25-f5f1-40e8-3b5c-f4de82adbe4c}">
           <p14:sldIdLst>
             <p14:sldId id="259"/>
             <p14:sldId id="260"/>
@@ -133,14 +133,14 @@
             <p14:sldId id="262"/>
           </p14:sldIdLst>
         </p14:section>
-        <p14:section name="Resultados" id="{47d6308c-1f17-9e21-7787-02da99fcb8a0}">
+        <p14:section name="Resultados" id="{dd42ace2-27a5-5805-a32b-795aadeab4a3}">
           <p14:sldIdLst>
             <p14:sldId id="263"/>
             <p14:sldId id="264"/>
             <p14:sldId id="265"/>
           </p14:sldIdLst>
         </p14:section>
-        <p14:section name="Conclusão" id="{28465f65-35f5-69b6-fc72-e232825bb676}">
+        <p14:section name="Conclusão" id="{b33399f2-4d12-baf1-006e-60e9c20f44ed}">
           <p14:sldIdLst>
             <p14:sldId id="266"/>
             <p14:sldId id="267"/>
@@ -12839,9 +12839,9 @@
 </file>
 
 <file path=ppt/theme/theme1.xml><?xml version="1.0" encoding="utf-8"?>
-<a:theme xmlns:a="http://schemas.openxmlformats.org/drawingml/2006/main" name="Verde Acadêmico">
+<a:theme xmlns:a="http://schemas.openxmlformats.org/drawingml/2006/main" name="Verde acadêmico">
   <a:themeElements>
-    <a:clrScheme name="Verde Acadêmico">
+    <a:clrScheme name="Verde acadêmico">
       <a:dk1>
         <a:srgbClr val="10281D"/>
       </a:dk1>
@@ -12879,7 +12879,7 @@
         <a:srgbClr val="4E6A5C"/>
       </a:folHlink>
     </a:clrScheme>
-    <a:fontScheme name="Verde Acadêmico">
+    <a:fontScheme name="Verde acadêmico">
       <a:majorFont>
         <a:latin typeface="Cambria"/>
         <a:ea typeface=""/>

</xml_diff>